<commit_message>
feat: finalizei todas as implementações do módulo04
</commit_message>
<xml_diff>
--- a/src/module04/content/Controle-de-Fluxo-em-Java.pptx
+++ b/src/module04/content/Controle-de-Fluxo-em-Java.pptx
@@ -25841,7 +25841,7 @@
         <p:spPr>
           <a:xfrm>
             <a:off x="0" y="0"/>
-            <a:ext cx="9144000" cy="960120"/>
+            <a:ext cx="9144000" cy="756356"/>
           </a:xfrm>
           <a:prstGeom prst="rect">
             <a:avLst/>
@@ -25929,7 +25929,7 @@
         </p:nvSpPr>
         <p:spPr>
           <a:xfrm>
-            <a:off x="310896" y="1115568"/>
+            <a:off x="352044" y="786610"/>
             <a:ext cx="8503920" cy="388620"/>
           </a:xfrm>
           <a:prstGeom prst="rect">
@@ -25979,7 +25979,7 @@
         </p:nvSpPr>
         <p:spPr>
           <a:xfrm>
-            <a:off x="310896" y="1572768"/>
+            <a:off x="352044" y="1049500"/>
             <a:ext cx="8503920" cy="388620"/>
           </a:xfrm>
           <a:prstGeom prst="rect">
@@ -26029,7 +26029,7 @@
         </p:nvSpPr>
         <p:spPr>
           <a:xfrm>
-            <a:off x="310896" y="2029968"/>
+            <a:off x="352044" y="1322564"/>
             <a:ext cx="8503920" cy="388620"/>
           </a:xfrm>
           <a:prstGeom prst="rect">
@@ -26079,7 +26079,7 @@
         </p:nvSpPr>
         <p:spPr>
           <a:xfrm>
-            <a:off x="310896" y="2487168"/>
+            <a:off x="352044" y="1527909"/>
             <a:ext cx="8503920" cy="388620"/>
           </a:xfrm>
           <a:prstGeom prst="rect">
@@ -26129,7 +26129,7 @@
         </p:nvSpPr>
         <p:spPr>
           <a:xfrm>
-            <a:off x="256032" y="2898648"/>
+            <a:off x="315468" y="1972508"/>
             <a:ext cx="8631936" cy="402336"/>
           </a:xfrm>
           <a:prstGeom prst="rect">
@@ -26154,7 +26154,7 @@
         </p:nvSpPr>
         <p:spPr>
           <a:xfrm>
-            <a:off x="420624" y="2935224"/>
+            <a:off x="480060" y="2009084"/>
             <a:ext cx="8375904" cy="374904"/>
           </a:xfrm>
           <a:prstGeom prst="rect">
@@ -26193,7 +26193,7 @@
         </p:nvSpPr>
         <p:spPr>
           <a:xfrm>
-            <a:off x="256032" y="3355848"/>
+            <a:off x="315468" y="2429708"/>
             <a:ext cx="8631936" cy="402336"/>
           </a:xfrm>
           <a:prstGeom prst="rect">
@@ -26218,7 +26218,7 @@
         </p:nvSpPr>
         <p:spPr>
           <a:xfrm>
-            <a:off x="420624" y="3392424"/>
+            <a:off x="480060" y="2466284"/>
             <a:ext cx="8375904" cy="374904"/>
           </a:xfrm>
           <a:prstGeom prst="rect">
@@ -26257,7 +26257,7 @@
         </p:nvSpPr>
         <p:spPr>
           <a:xfrm>
-            <a:off x="256032" y="3813048"/>
+            <a:off x="315468" y="2886908"/>
             <a:ext cx="8631936" cy="402336"/>
           </a:xfrm>
           <a:prstGeom prst="rect">
@@ -26282,7 +26282,7 @@
         </p:nvSpPr>
         <p:spPr>
           <a:xfrm>
-            <a:off x="420624" y="3849624"/>
+            <a:off x="480060" y="2923484"/>
             <a:ext cx="8375904" cy="374904"/>
           </a:xfrm>
           <a:prstGeom prst="rect">
@@ -26321,7 +26321,7 @@
         </p:nvSpPr>
         <p:spPr>
           <a:xfrm>
-            <a:off x="256032" y="4270248"/>
+            <a:off x="315468" y="3344108"/>
             <a:ext cx="8631936" cy="402336"/>
           </a:xfrm>
           <a:prstGeom prst="rect">
@@ -26346,7 +26346,7 @@
         </p:nvSpPr>
         <p:spPr>
           <a:xfrm>
-            <a:off x="420624" y="4306824"/>
+            <a:off x="480060" y="3380684"/>
             <a:ext cx="8375904" cy="374904"/>
           </a:xfrm>
           <a:prstGeom prst="rect">
@@ -26385,7 +26385,7 @@
         </p:nvSpPr>
         <p:spPr>
           <a:xfrm>
-            <a:off x="256032" y="4727448"/>
+            <a:off x="315468" y="3801308"/>
             <a:ext cx="8631936" cy="402336"/>
           </a:xfrm>
           <a:prstGeom prst="rect">
@@ -26410,7 +26410,7 @@
         </p:nvSpPr>
         <p:spPr>
           <a:xfrm>
-            <a:off x="420624" y="4764024"/>
+            <a:off x="480060" y="3837884"/>
             <a:ext cx="8375904" cy="374904"/>
           </a:xfrm>
           <a:prstGeom prst="rect">
@@ -26449,7 +26449,7 @@
         </p:nvSpPr>
         <p:spPr>
           <a:xfrm>
-            <a:off x="256032" y="5184648"/>
+            <a:off x="315468" y="4258508"/>
             <a:ext cx="8631936" cy="402336"/>
           </a:xfrm>
           <a:prstGeom prst="rect">
@@ -26476,7 +26476,7 @@
         </p:nvSpPr>
         <p:spPr>
           <a:xfrm>
-            <a:off x="457200" y="5221224"/>
+            <a:off x="516636" y="4295084"/>
             <a:ext cx="8412480" cy="374904"/>
           </a:xfrm>
           <a:prstGeom prst="rect">
@@ -26565,7 +26565,7 @@
         </p:nvSpPr>
         <p:spPr>
           <a:xfrm>
-            <a:off x="274320" y="4937760"/>
+            <a:off x="274320" y="4928616"/>
             <a:ext cx="5486400" cy="182880"/>
           </a:xfrm>
           <a:prstGeom prst="rect">
@@ -26826,8 +26826,8 @@
         </p:nvSpPr>
         <p:spPr>
           <a:xfrm>
-            <a:off x="256032" y="1911096"/>
-            <a:ext cx="8631936" cy="370149"/>
+            <a:off x="233172" y="1893722"/>
+            <a:ext cx="8631936" cy="3278672"/>
           </a:xfrm>
           <a:prstGeom prst="rect">
             <a:avLst/>
@@ -26852,7 +26852,7 @@
         <p:spPr>
           <a:xfrm>
             <a:off x="420624" y="1947672"/>
-            <a:ext cx="8375904" cy="344912"/>
+            <a:ext cx="8375904" cy="213021"/>
           </a:xfrm>
           <a:prstGeom prst="rect">
             <a:avLst/>
@@ -26884,31 +26884,6 @@
       </p:sp>
       <p:sp>
         <p:nvSpPr>
-          <p:cNvPr id="9" name="Shape 7"/>
-          <p:cNvSpPr/>
-          <p:nvPr/>
-        </p:nvSpPr>
-        <p:spPr>
-          <a:xfrm>
-            <a:off x="256032" y="2331720"/>
-            <a:ext cx="8631936" cy="370149"/>
-          </a:xfrm>
-          <a:prstGeom prst="rect">
-            <a:avLst/>
-          </a:prstGeom>
-          <a:solidFill>
-            <a:srgbClr val="0E0619"/>
-          </a:solidFill>
-          <a:ln w="7620">
-            <a:solidFill>
-              <a:srgbClr val="7C3AED"/>
-            </a:solidFill>
-            <a:prstDash val="solid"/>
-          </a:ln>
-        </p:spPr>
-      </p:sp>
-      <p:sp>
-        <p:nvSpPr>
           <p:cNvPr id="10" name="Text 8"/>
           <p:cNvSpPr/>
           <p:nvPr/>
@@ -26916,7 +26891,7 @@
         <p:spPr>
           <a:xfrm>
             <a:off x="420624" y="2368296"/>
-            <a:ext cx="8375904" cy="344912"/>
+            <a:ext cx="8375904" cy="213021"/>
           </a:xfrm>
           <a:prstGeom prst="rect">
             <a:avLst/>
@@ -26948,39 +26923,14 @@
       </p:sp>
       <p:sp>
         <p:nvSpPr>
-          <p:cNvPr id="11" name="Shape 9"/>
-          <p:cNvSpPr/>
-          <p:nvPr/>
-        </p:nvSpPr>
-        <p:spPr>
-          <a:xfrm>
-            <a:off x="256032" y="2752344"/>
-            <a:ext cx="8631936" cy="370149"/>
-          </a:xfrm>
-          <a:prstGeom prst="rect">
-            <a:avLst/>
-          </a:prstGeom>
-          <a:solidFill>
-            <a:srgbClr val="0E0619"/>
-          </a:solidFill>
-          <a:ln w="7620">
-            <a:solidFill>
-              <a:srgbClr val="7C3AED"/>
-            </a:solidFill>
-            <a:prstDash val="solid"/>
-          </a:ln>
-        </p:spPr>
-      </p:sp>
-      <p:sp>
-        <p:nvSpPr>
           <p:cNvPr id="12" name="Text 10"/>
           <p:cNvSpPr/>
           <p:nvPr/>
         </p:nvSpPr>
         <p:spPr>
           <a:xfrm>
-            <a:off x="420624" y="2788920"/>
-            <a:ext cx="8375904" cy="344912"/>
+            <a:off x="420624" y="2575899"/>
+            <a:ext cx="8375904" cy="213021"/>
           </a:xfrm>
           <a:prstGeom prst="rect">
             <a:avLst/>
@@ -27012,39 +26962,14 @@
       </p:sp>
       <p:sp>
         <p:nvSpPr>
-          <p:cNvPr id="13" name="Shape 11"/>
-          <p:cNvSpPr/>
-          <p:nvPr/>
-        </p:nvSpPr>
-        <p:spPr>
-          <a:xfrm>
-            <a:off x="256032" y="3172968"/>
-            <a:ext cx="8631936" cy="370149"/>
-          </a:xfrm>
-          <a:prstGeom prst="rect">
-            <a:avLst/>
-          </a:prstGeom>
-          <a:solidFill>
-            <a:srgbClr val="0E0619"/>
-          </a:solidFill>
-          <a:ln w="7620">
-            <a:solidFill>
-              <a:srgbClr val="7C3AED"/>
-            </a:solidFill>
-            <a:prstDash val="solid"/>
-          </a:ln>
-        </p:spPr>
-      </p:sp>
-      <p:sp>
-        <p:nvSpPr>
           <p:cNvPr id="14" name="Text 12"/>
           <p:cNvSpPr/>
           <p:nvPr/>
         </p:nvSpPr>
         <p:spPr>
           <a:xfrm>
-            <a:off x="420624" y="3209544"/>
-            <a:ext cx="8375904" cy="344912"/>
+            <a:off x="420624" y="2996523"/>
+            <a:ext cx="8375904" cy="213021"/>
           </a:xfrm>
           <a:prstGeom prst="rect">
             <a:avLst/>
@@ -27076,39 +27001,14 @@
       </p:sp>
       <p:sp>
         <p:nvSpPr>
-          <p:cNvPr id="15" name="Shape 13"/>
-          <p:cNvSpPr/>
-          <p:nvPr/>
-        </p:nvSpPr>
-        <p:spPr>
-          <a:xfrm>
-            <a:off x="256032" y="3593592"/>
-            <a:ext cx="8631936" cy="370149"/>
-          </a:xfrm>
-          <a:prstGeom prst="rect">
-            <a:avLst/>
-          </a:prstGeom>
-          <a:solidFill>
-            <a:srgbClr val="0E0619"/>
-          </a:solidFill>
-          <a:ln w="7620">
-            <a:solidFill>
-              <a:srgbClr val="7C3AED"/>
-            </a:solidFill>
-            <a:prstDash val="solid"/>
-          </a:ln>
-        </p:spPr>
-      </p:sp>
-      <p:sp>
-        <p:nvSpPr>
           <p:cNvPr id="16" name="Text 14"/>
           <p:cNvSpPr/>
           <p:nvPr/>
         </p:nvSpPr>
         <p:spPr>
           <a:xfrm>
-            <a:off x="420624" y="3630168"/>
-            <a:ext cx="8375904" cy="344912"/>
+            <a:off x="420624" y="3417147"/>
+            <a:ext cx="8375904" cy="213021"/>
           </a:xfrm>
           <a:prstGeom prst="rect">
             <a:avLst/>
@@ -27140,39 +27040,14 @@
       </p:sp>
       <p:sp>
         <p:nvSpPr>
-          <p:cNvPr id="17" name="Shape 15"/>
-          <p:cNvSpPr/>
-          <p:nvPr/>
-        </p:nvSpPr>
-        <p:spPr>
-          <a:xfrm>
-            <a:off x="256032" y="4014216"/>
-            <a:ext cx="8631936" cy="370149"/>
-          </a:xfrm>
-          <a:prstGeom prst="rect">
-            <a:avLst/>
-          </a:prstGeom>
-          <a:solidFill>
-            <a:srgbClr val="0E0619"/>
-          </a:solidFill>
-          <a:ln w="7620">
-            <a:solidFill>
-              <a:srgbClr val="7C3AED"/>
-            </a:solidFill>
-            <a:prstDash val="solid"/>
-          </a:ln>
-        </p:spPr>
-      </p:sp>
-      <p:sp>
-        <p:nvSpPr>
           <p:cNvPr id="18" name="Text 16"/>
           <p:cNvSpPr/>
           <p:nvPr/>
         </p:nvSpPr>
         <p:spPr>
           <a:xfrm>
-            <a:off x="420624" y="4050792"/>
-            <a:ext cx="8375904" cy="344912"/>
+            <a:off x="420624" y="3679038"/>
+            <a:ext cx="8375904" cy="213021"/>
           </a:xfrm>
           <a:prstGeom prst="rect">
             <a:avLst/>
@@ -27204,39 +27079,14 @@
       </p:sp>
       <p:sp>
         <p:nvSpPr>
-          <p:cNvPr id="19" name="Shape 17"/>
-          <p:cNvSpPr/>
-          <p:nvPr/>
-        </p:nvSpPr>
-        <p:spPr>
-          <a:xfrm>
-            <a:off x="256032" y="4434840"/>
-            <a:ext cx="8631936" cy="370149"/>
-          </a:xfrm>
-          <a:prstGeom prst="rect">
-            <a:avLst/>
-          </a:prstGeom>
-          <a:solidFill>
-            <a:srgbClr val="0E0619"/>
-          </a:solidFill>
-          <a:ln w="7620">
-            <a:solidFill>
-              <a:srgbClr val="7C3AED"/>
-            </a:solidFill>
-            <a:prstDash val="solid"/>
-          </a:ln>
-        </p:spPr>
-      </p:sp>
-      <p:sp>
-        <p:nvSpPr>
           <p:cNvPr id="20" name="Text 18"/>
           <p:cNvSpPr/>
           <p:nvPr/>
         </p:nvSpPr>
         <p:spPr>
           <a:xfrm>
-            <a:off x="420624" y="4471416"/>
-            <a:ext cx="8375904" cy="344912"/>
+            <a:off x="420624" y="4008809"/>
+            <a:ext cx="8375904" cy="213021"/>
           </a:xfrm>
           <a:prstGeom prst="rect">
             <a:avLst/>
@@ -27268,39 +27118,14 @@
       </p:sp>
       <p:sp>
         <p:nvSpPr>
-          <p:cNvPr id="21" name="Shape 19"/>
-          <p:cNvSpPr/>
-          <p:nvPr/>
-        </p:nvSpPr>
-        <p:spPr>
-          <a:xfrm>
-            <a:off x="256032" y="4855464"/>
-            <a:ext cx="8631936" cy="370149"/>
-          </a:xfrm>
-          <a:prstGeom prst="rect">
-            <a:avLst/>
-          </a:prstGeom>
-          <a:solidFill>
-            <a:srgbClr val="0E0619"/>
-          </a:solidFill>
-          <a:ln w="7620">
-            <a:solidFill>
-              <a:srgbClr val="7C3AED"/>
-            </a:solidFill>
-            <a:prstDash val="solid"/>
-          </a:ln>
-        </p:spPr>
-      </p:sp>
-      <p:sp>
-        <p:nvSpPr>
           <p:cNvPr id="22" name="Text 20"/>
           <p:cNvSpPr/>
           <p:nvPr/>
         </p:nvSpPr>
         <p:spPr>
           <a:xfrm>
-            <a:off x="420624" y="4892040"/>
-            <a:ext cx="8375904" cy="344912"/>
+            <a:off x="420624" y="4214492"/>
+            <a:ext cx="8375904" cy="213021"/>
           </a:xfrm>
           <a:prstGeom prst="rect">
             <a:avLst/>
@@ -27332,39 +27157,14 @@
       </p:sp>
       <p:sp>
         <p:nvSpPr>
-          <p:cNvPr id="23" name="Shape 21"/>
-          <p:cNvSpPr/>
-          <p:nvPr/>
-        </p:nvSpPr>
-        <p:spPr>
-          <a:xfrm>
-            <a:off x="256032" y="5276088"/>
-            <a:ext cx="8631936" cy="370149"/>
-          </a:xfrm>
-          <a:prstGeom prst="rect">
-            <a:avLst/>
-          </a:prstGeom>
-          <a:solidFill>
-            <a:srgbClr val="0E0619"/>
-          </a:solidFill>
-          <a:ln w="7620">
-            <a:solidFill>
-              <a:srgbClr val="7C3AED"/>
-            </a:solidFill>
-            <a:prstDash val="solid"/>
-          </a:ln>
-        </p:spPr>
-      </p:sp>
-      <p:sp>
-        <p:nvSpPr>
           <p:cNvPr id="24" name="Text 22"/>
           <p:cNvSpPr/>
           <p:nvPr/>
         </p:nvSpPr>
         <p:spPr>
           <a:xfrm>
-            <a:off x="420624" y="5312664"/>
-            <a:ext cx="8375904" cy="344912"/>
+            <a:off x="457200" y="4448714"/>
+            <a:ext cx="8375904" cy="213021"/>
           </a:xfrm>
           <a:prstGeom prst="rect">
             <a:avLst/>
@@ -27396,39 +27196,14 @@
       </p:sp>
       <p:sp>
         <p:nvSpPr>
-          <p:cNvPr id="25" name="Shape 23"/>
-          <p:cNvSpPr/>
-          <p:nvPr/>
-        </p:nvSpPr>
-        <p:spPr>
-          <a:xfrm>
-            <a:off x="256032" y="5696712"/>
-            <a:ext cx="8631936" cy="370149"/>
-          </a:xfrm>
-          <a:prstGeom prst="rect">
-            <a:avLst/>
-          </a:prstGeom>
-          <a:solidFill>
-            <a:srgbClr val="0E0619"/>
-          </a:solidFill>
-          <a:ln w="7620">
-            <a:solidFill>
-              <a:srgbClr val="7C3AED"/>
-            </a:solidFill>
-            <a:prstDash val="solid"/>
-          </a:ln>
-        </p:spPr>
-      </p:sp>
-      <p:sp>
-        <p:nvSpPr>
           <p:cNvPr id="26" name="Text 24"/>
           <p:cNvSpPr/>
           <p:nvPr/>
         </p:nvSpPr>
         <p:spPr>
           <a:xfrm>
-            <a:off x="420624" y="5733288"/>
-            <a:ext cx="8375904" cy="344912"/>
+            <a:off x="448056" y="4697482"/>
+            <a:ext cx="8375904" cy="213021"/>
           </a:xfrm>
           <a:prstGeom prst="rect">
             <a:avLst/>
@@ -27460,39 +27235,14 @@
       </p:sp>
       <p:sp>
         <p:nvSpPr>
-          <p:cNvPr id="27" name="Shape 25"/>
-          <p:cNvSpPr/>
-          <p:nvPr/>
-        </p:nvSpPr>
-        <p:spPr>
-          <a:xfrm>
-            <a:off x="256032" y="6117336"/>
-            <a:ext cx="8631936" cy="370149"/>
-          </a:xfrm>
-          <a:prstGeom prst="rect">
-            <a:avLst/>
-          </a:prstGeom>
-          <a:solidFill>
-            <a:srgbClr val="0E0619"/>
-          </a:solidFill>
-          <a:ln w="7620">
-            <a:solidFill>
-              <a:srgbClr val="7C3AED"/>
-            </a:solidFill>
-            <a:prstDash val="solid"/>
-          </a:ln>
-        </p:spPr>
-      </p:sp>
-      <p:sp>
-        <p:nvSpPr>
           <p:cNvPr id="28" name="Text 26"/>
           <p:cNvSpPr/>
           <p:nvPr/>
         </p:nvSpPr>
         <p:spPr>
           <a:xfrm>
-            <a:off x="420624" y="6153912"/>
-            <a:ext cx="8375904" cy="344912"/>
+            <a:off x="448056" y="4959373"/>
+            <a:ext cx="8375904" cy="213021"/>
           </a:xfrm>
           <a:prstGeom prst="rect">
             <a:avLst/>
@@ -27519,95 +27269,6 @@
               <a:t>if (min != Double.MAX_VALUE) System.out.println("Min: " + min + " Max: " + max);</a:t>
             </a:r>
             <a:endParaRPr lang="en-US" sz="1300" dirty="0"/>
-          </a:p>
-        </p:txBody>
-      </p:sp>
-      <p:sp>
-        <p:nvSpPr>
-          <p:cNvPr id="29" name="Shape 27"/>
-          <p:cNvSpPr/>
-          <p:nvPr/>
-        </p:nvSpPr>
-        <p:spPr>
-          <a:xfrm>
-            <a:off x="0" y="4919472"/>
-            <a:ext cx="9144000" cy="224028"/>
-          </a:xfrm>
-          <a:prstGeom prst="rect">
-            <a:avLst/>
-          </a:prstGeom>
-          <a:solidFill>
-            <a:srgbClr val="12091E"/>
-          </a:solidFill>
-          <a:ln w="12700">
-            <a:solidFill>
-              <a:srgbClr val="12091E"/>
-            </a:solidFill>
-            <a:prstDash val="solid"/>
-          </a:ln>
-        </p:spPr>
-      </p:sp>
-      <p:sp>
-        <p:nvSpPr>
-          <p:cNvPr id="30" name="Shape 28"/>
-          <p:cNvSpPr/>
-          <p:nvPr/>
-        </p:nvSpPr>
-        <p:spPr>
-          <a:xfrm>
-            <a:off x="0" y="4919472"/>
-            <a:ext cx="64008" cy="224028"/>
-          </a:xfrm>
-          <a:prstGeom prst="rect">
-            <a:avLst/>
-          </a:prstGeom>
-          <a:solidFill>
-            <a:srgbClr val="7C3AED"/>
-          </a:solidFill>
-          <a:ln w="12700">
-            <a:solidFill>
-              <a:srgbClr val="7C3AED"/>
-            </a:solidFill>
-            <a:prstDash val="solid"/>
-          </a:ln>
-        </p:spPr>
-      </p:sp>
-      <p:sp>
-        <p:nvSpPr>
-          <p:cNvPr id="31" name="Text 29"/>
-          <p:cNvSpPr/>
-          <p:nvPr/>
-        </p:nvSpPr>
-        <p:spPr>
-          <a:xfrm>
-            <a:off x="274320" y="4937760"/>
-            <a:ext cx="5486400" cy="182880"/>
-          </a:xfrm>
-          <a:prstGeom prst="rect">
-            <a:avLst/>
-          </a:prstGeom>
-          <a:noFill/>
-          <a:ln/>
-        </p:spPr>
-        <p:txBody>
-          <a:bodyPr wrap="square" lIns="0" tIns="0" rIns="0" bIns="0" rtlCol="0" anchor="ctr"/>
-          <a:lstStyle/>
-          <a:p>
-            <a:pPr marL="0" indent="0">
-              <a:buNone/>
-            </a:pPr>
-            <a:r>
-              <a:rPr lang="en-US" sz="900" dirty="0">
-                <a:solidFill>
-                  <a:srgbClr val="CBD5E1"/>
-                </a:solidFill>
-                <a:latin typeface="Calibri" pitchFamily="34" charset="0"/>
-                <a:ea typeface="Calibri" pitchFamily="34" charset="-122"/>
-                <a:cs typeface="Calibri" pitchFamily="34" charset="-120"/>
-              </a:rPr>
-              <a:t>Controle de Fluxo em Java</a:t>
-            </a:r>
-            <a:endParaRPr lang="en-US" sz="900" dirty="0"/>
           </a:p>
         </p:txBody>
       </p:sp>

</xml_diff>